<commit_message>
Redesign Figure 1 as a structured roadmap; set figure text in Times New Roman
- Figure 1: four rows (foundations, components, evaluation, outlook); components follow the title (LLMs, harness architectures from general to specific); layer colours match Figure 3; built from an editable PPTX
- Figures 4-15: all text runs in Times New Roman (replacing Comic Sans headings and Arial labels); layout, icons, and colours unchanged
- Caption and Section 1 text describe the new organization figure

Co-Authored-By: Claude Opus 5.5 <noreply@anthropic.com>
</commit_message>
<xml_diff>
--- a/artifacts/editorial_accent_20261022/pptx/Figure05_Accent.pptx
+++ b/artifacts/editorial_accent_20261022/pptx/Figure05_Accent.pptx
@@ -1143,7 +1143,7 @@
                     <ns7:solidFill>
                       <ns7:srgbClr val="222222"/>
                     </ns7:solidFill>
-                    <ns7:latin typeface="Comic Sans MS"/>
+                    <ns7:latin typeface="Times New Roman"/>
                     <ns7:ea typeface="Times New Roman"/>
                   </ns7:rPr>
                   <ns7:t>Representation &amp; alignment</ns7:t>
@@ -1200,6 +1200,10 @@
                   </ns4:solidFill>
                 </ns4:ln>
               </p:spPr>
+              <p:txBody xmlns:a="http://schemas.openxmlformats.org/drawingml/2006/main">
+                <a:bodyPr/>
+                <a:p/>
+              </p:txBody>
             </p:sp>
             <p:sp>
               <p:nvSpPr>
@@ -1236,6 +1240,10 @@
                   </ns4:solidFill>
                 </ns4:ln>
               </p:spPr>
+              <p:txBody xmlns:a="http://schemas.openxmlformats.org/drawingml/2006/main">
+                <a:bodyPr/>
+                <a:p/>
+              </p:txBody>
             </p:sp>
             <p:sp>
               <p:nvSpPr>
@@ -1272,6 +1280,10 @@
                   </ns4:solidFill>
                 </ns4:ln>
               </p:spPr>
+              <p:txBody xmlns:a="http://schemas.openxmlformats.org/drawingml/2006/main">
+                <a:bodyPr/>
+                <a:p/>
+              </p:txBody>
             </p:sp>
             <p:sp>
               <p:nvSpPr>
@@ -1329,6 +1341,10 @@
                   </ns4:solidFill>
                 </ns4:ln>
               </p:spPr>
+              <p:txBody xmlns:a="http://schemas.openxmlformats.org/drawingml/2006/main">
+                <a:bodyPr/>
+                <a:p/>
+              </p:txBody>
             </p:sp>
             <p:sp>
               <p:nvSpPr>
@@ -1365,6 +1381,10 @@
                   </ns4:solidFill>
                 </ns4:ln>
               </p:spPr>
+              <p:txBody xmlns:a="http://schemas.openxmlformats.org/drawingml/2006/main">
+                <a:bodyPr/>
+                <a:p/>
+              </p:txBody>
             </p:sp>
             <p:sp>
               <p:nvSpPr>
@@ -1401,6 +1421,10 @@
                   </ns4:solidFill>
                 </ns4:ln>
               </p:spPr>
+              <p:txBody xmlns:a="http://schemas.openxmlformats.org/drawingml/2006/main">
+                <a:bodyPr/>
+                <a:p/>
+              </p:txBody>
             </p:sp>
           </p:grpSp>
           <p:grpSp>
@@ -1492,6 +1516,10 @@
                   </ns4:solidFill>
                 </ns4:ln>
               </p:spPr>
+              <p:txBody xmlns:a="http://schemas.openxmlformats.org/drawingml/2006/main">
+                <a:bodyPr/>
+                <a:p/>
+              </p:txBody>
             </p:sp>
             <p:sp>
               <p:nvSpPr>
@@ -1546,6 +1574,10 @@
                   </ns4:solidFill>
                 </ns4:ln>
               </p:spPr>
+              <p:txBody xmlns:a="http://schemas.openxmlformats.org/drawingml/2006/main">
+                <a:bodyPr/>
+                <a:p/>
+              </p:txBody>
             </p:sp>
             <p:sp>
               <p:nvSpPr>
@@ -1600,6 +1632,10 @@
                   </ns4:solidFill>
                 </ns4:ln>
               </p:spPr>
+              <p:txBody xmlns:a="http://schemas.openxmlformats.org/drawingml/2006/main">
+                <a:bodyPr/>
+                <a:p/>
+              </p:txBody>
             </p:sp>
           </p:grpSp>
           <p:sp>
@@ -1653,6 +1689,10 @@
                 </ns0:outerShdw>
               </ns0:effectLst>
             </p:spPr>
+            <p:txBody xmlns:a="http://schemas.openxmlformats.org/drawingml/2006/main">
+              <a:bodyPr/>
+              <a:p/>
+            </p:txBody>
           </p:sp>
           <p:sp>
             <p:nvSpPr>
@@ -1683,7 +1723,7 @@
                     <ns7:solidFill>
                       <ns7:srgbClr val="222222"/>
                     </ns7:solidFill>
-                    <ns7:latin typeface="Arial"/>
+                    <ns7:latin typeface="Times New Roman"/>
                     <ns7:ea typeface="Times New Roman"/>
                   </ns7:rPr>
                   <ns7:t>Series patches</ns7:t>
@@ -1720,7 +1760,7 @@
                     <ns7:solidFill>
                       <ns7:srgbClr val="222222"/>
                     </ns7:solidFill>
-                    <ns7:latin typeface="Arial"/>
+                    <ns7:latin typeface="Times New Roman"/>
                     <ns7:ea typeface="Times New Roman"/>
                   </ns7:rPr>
                   <ns7:t>Language space</ns7:t>
@@ -1757,7 +1797,7 @@
                     <ns7:solidFill>
                       <ns7:srgbClr val="222222"/>
                     </ns7:solidFill>
-                    <ns7:latin typeface="Arial"/>
+                    <ns7:latin typeface="Times New Roman"/>
                     <ns7:ea typeface="Times New Roman"/>
                   </ns7:rPr>
                   <ns7:t>Scale and temporal structure</ns7:t>
@@ -1809,7 +1849,7 @@
                     <ns7:solidFill>
                       <ns7:srgbClr val="222222"/>
                     </ns7:solidFill>
-                    <ns7:latin typeface="Comic Sans MS"/>
+                    <ns7:latin typeface="Times New Roman"/>
                     <ns7:ea typeface="Times New Roman"/>
                   </ns7:rPr>
                   <ns7:t>Instruction &amp; reasoning</ns7:t>
@@ -1904,6 +1944,10 @@
                   </ns4:solidFill>
                 </ns4:ln>
               </p:spPr>
+              <p:txBody xmlns:a="http://schemas.openxmlformats.org/drawingml/2006/main">
+                <a:bodyPr/>
+                <a:p/>
+              </p:txBody>
             </p:sp>
             <p:sp>
               <p:nvSpPr>
@@ -1948,6 +1992,10 @@
                   </ns4:solidFill>
                 </ns4:ln>
               </p:spPr>
+              <p:txBody xmlns:a="http://schemas.openxmlformats.org/drawingml/2006/main">
+                <a:bodyPr/>
+                <a:p/>
+              </p:txBody>
             </p:sp>
             <p:sp>
               <p:nvSpPr>
@@ -1984,6 +2032,10 @@
                   </ns4:solidFill>
                 </ns4:ln>
               </p:spPr>
+              <p:txBody xmlns:a="http://schemas.openxmlformats.org/drawingml/2006/main">
+                <a:bodyPr/>
+                <a:p/>
+              </p:txBody>
             </p:sp>
             <p:sp>
               <p:nvSpPr>
@@ -2020,6 +2072,10 @@
                   </ns4:solidFill>
                 </ns4:ln>
               </p:spPr>
+              <p:txBody xmlns:a="http://schemas.openxmlformats.org/drawingml/2006/main">
+                <a:bodyPr/>
+                <a:p/>
+              </p:txBody>
             </p:sp>
             <p:sp>
               <p:nvSpPr>
@@ -2056,6 +2112,10 @@
                   </ns4:solidFill>
                 </ns4:ln>
               </p:spPr>
+              <p:txBody xmlns:a="http://schemas.openxmlformats.org/drawingml/2006/main">
+                <a:bodyPr/>
+                <a:p/>
+              </p:txBody>
             </p:sp>
           </p:grpSp>
           <p:grpSp>
@@ -2107,6 +2167,10 @@
                   </ns4:solidFill>
                 </ns4:ln>
               </p:spPr>
+              <p:txBody xmlns:a="http://schemas.openxmlformats.org/drawingml/2006/main">
+                <a:bodyPr/>
+                <a:p/>
+              </p:txBody>
             </p:sp>
             <p:sp>
               <p:nvSpPr>
@@ -2151,6 +2215,10 @@
                   </ns4:solidFill>
                 </ns4:ln>
               </p:spPr>
+              <p:txBody xmlns:a="http://schemas.openxmlformats.org/drawingml/2006/main">
+                <a:bodyPr/>
+                <a:p/>
+              </p:txBody>
             </p:sp>
             <p:sp>
               <p:nvSpPr>
@@ -2187,6 +2255,10 @@
                   </ns4:solidFill>
                 </ns4:ln>
               </p:spPr>
+              <p:txBody xmlns:a="http://schemas.openxmlformats.org/drawingml/2006/main">
+                <a:bodyPr/>
+                <a:p/>
+              </p:txBody>
             </p:sp>
             <p:sp>
               <p:nvSpPr>
@@ -2225,6 +2297,10 @@
                   </ns4:solidFill>
                 </ns4:ln>
               </p:spPr>
+              <p:txBody xmlns:a="http://schemas.openxmlformats.org/drawingml/2006/main">
+                <a:bodyPr/>
+                <a:p/>
+              </p:txBody>
             </p:sp>
             <p:sp>
               <p:nvSpPr>
@@ -2266,6 +2342,10 @@
                   </ns4:solidFill>
                 </ns4:ln>
               </p:spPr>
+              <p:txBody xmlns:a="http://schemas.openxmlformats.org/drawingml/2006/main">
+                <a:bodyPr/>
+                <a:p/>
+              </p:txBody>
             </p:sp>
             <p:sp>
               <p:nvSpPr>
@@ -2309,6 +2389,10 @@
                   </ns4:solidFill>
                 </ns4:ln>
               </p:spPr>
+              <p:txBody xmlns:a="http://schemas.openxmlformats.org/drawingml/2006/main">
+                <a:bodyPr/>
+                <a:p/>
+              </p:txBody>
             </p:sp>
             <p:sp>
               <p:nvSpPr>
@@ -2352,6 +2436,10 @@
                   </ns4:solidFill>
                 </ns4:ln>
               </p:spPr>
+              <p:txBody xmlns:a="http://schemas.openxmlformats.org/drawingml/2006/main">
+                <a:bodyPr/>
+                <a:p/>
+              </p:txBody>
             </p:sp>
             <p:sp>
               <p:nvSpPr>
@@ -2418,6 +2506,10 @@
                   </ns4:solidFill>
                 </ns4:ln>
               </p:spPr>
+              <p:txBody xmlns:a="http://schemas.openxmlformats.org/drawingml/2006/main">
+                <a:bodyPr/>
+                <a:p/>
+              </p:txBody>
             </p:sp>
             <p:sp>
               <p:nvSpPr>
@@ -2440,6 +2532,10 @@
                   </ns5:solidFill>
                 </ns5:ln>
               </p:spPr>
+              <p:txBody xmlns:a="http://schemas.openxmlformats.org/drawingml/2006/main">
+                <a:bodyPr/>
+                <a:p/>
+              </p:txBody>
             </p:sp>
             <p:sp>
               <p:nvSpPr>
@@ -2462,6 +2558,10 @@
                   </ns5:solidFill>
                 </ns5:ln>
               </p:spPr>
+              <p:txBody xmlns:a="http://schemas.openxmlformats.org/drawingml/2006/main">
+                <a:bodyPr/>
+                <a:p/>
+              </p:txBody>
             </p:sp>
             <p:sp>
               <p:nvSpPr>
@@ -2484,6 +2584,10 @@
                   </ns5:solidFill>
                 </ns5:ln>
               </p:spPr>
+              <p:txBody xmlns:a="http://schemas.openxmlformats.org/drawingml/2006/main">
+                <a:bodyPr/>
+                <a:p/>
+              </p:txBody>
             </p:sp>
             <p:sp>
               <p:nvSpPr>
@@ -2506,6 +2610,10 @@
                   </ns5:solidFill>
                 </ns5:ln>
               </p:spPr>
+              <p:txBody xmlns:a="http://schemas.openxmlformats.org/drawingml/2006/main">
+                <a:bodyPr/>
+                <a:p/>
+              </p:txBody>
             </p:sp>
           </p:grpSp>
           <p:sp>
@@ -2559,6 +2667,10 @@
                 </ns1:outerShdw>
               </ns1:effectLst>
             </p:spPr>
+            <p:txBody xmlns:a="http://schemas.openxmlformats.org/drawingml/2006/main">
+              <a:bodyPr/>
+              <a:p/>
+            </p:txBody>
           </p:sp>
           <p:sp>
             <p:nvSpPr>
@@ -2589,7 +2701,7 @@
                     <ns7:solidFill>
                       <ns7:srgbClr val="222222"/>
                     </ns7:solidFill>
-                    <ns7:latin typeface="Arial"/>
+                    <ns7:latin typeface="Times New Roman"/>
                     <ns7:ea typeface="Times New Roman"/>
                   </ns7:rPr>
                   <ns7:t>Temporal questions</ns7:t>
@@ -2626,7 +2738,7 @@
                     <ns7:solidFill>
                       <ns7:srgbClr val="222222"/>
                     </ns7:solidFill>
-                    <ns7:latin typeface="Arial"/>
+                    <ns7:latin typeface="Times New Roman"/>
                     <ns7:ea typeface="Times New Roman"/>
                   </ns7:rPr>
                   <ns7:t>Grounded answers</ns7:t>
@@ -2663,7 +2775,7 @@
                     <ns7:solidFill>
                       <ns7:srgbClr val="222222"/>
                     </ns7:solidFill>
-                    <ns7:latin typeface="Arial"/>
+                    <ns7:latin typeface="Times New Roman"/>
                     <ns7:ea typeface="Times New Roman"/>
                   </ns7:rPr>
                   <ns7:t>Instructions and outcome feedback</ns7:t>
@@ -2715,7 +2827,7 @@
                     <ns7:solidFill>
                       <ns7:srgbClr val="222222"/>
                     </ns7:solidFill>
-                    <ns7:latin typeface="Comic Sans MS"/>
+                    <ns7:latin typeface="Times New Roman"/>
                     <ns7:ea typeface="Times New Roman"/>
                   </ns7:rPr>
                   <ns7:t>Workflow learning</ns7:t>
@@ -2772,6 +2884,10 @@
                   </ns4:solidFill>
                 </ns4:ln>
               </p:spPr>
+              <p:txBody xmlns:a="http://schemas.openxmlformats.org/drawingml/2006/main">
+                <a:bodyPr/>
+                <a:p/>
+              </p:txBody>
             </p:sp>
             <p:sp>
               <p:nvSpPr>
@@ -2808,6 +2924,10 @@
                   </ns4:solidFill>
                 </ns4:ln>
               </p:spPr>
+              <p:txBody xmlns:a="http://schemas.openxmlformats.org/drawingml/2006/main">
+                <a:bodyPr/>
+                <a:p/>
+              </p:txBody>
             </p:sp>
             <p:sp>
               <p:nvSpPr>
@@ -2844,6 +2964,10 @@
                   </ns4:solidFill>
                 </ns4:ln>
               </p:spPr>
+              <p:txBody xmlns:a="http://schemas.openxmlformats.org/drawingml/2006/main">
+                <a:bodyPr/>
+                <a:p/>
+              </p:txBody>
             </p:sp>
             <p:sp>
               <p:nvSpPr>
@@ -2883,6 +3007,10 @@
                   </ns4:solidFill>
                 </ns4:ln>
               </p:spPr>
+              <p:txBody xmlns:a="http://schemas.openxmlformats.org/drawingml/2006/main">
+                <a:bodyPr/>
+                <a:p/>
+              </p:txBody>
             </p:sp>
             <p:sp>
               <p:nvSpPr>
@@ -2922,6 +3050,10 @@
                   </ns4:solidFill>
                 </ns4:ln>
               </p:spPr>
+              <p:txBody xmlns:a="http://schemas.openxmlformats.org/drawingml/2006/main">
+                <a:bodyPr/>
+                <a:p/>
+              </p:txBody>
             </p:sp>
           </p:grpSp>
           <p:grpSp>
@@ -3036,6 +3168,10 @@
                   </ns4:solidFill>
                 </ns4:ln>
               </p:spPr>
+              <p:txBody xmlns:a="http://schemas.openxmlformats.org/drawingml/2006/main">
+                <a:bodyPr/>
+                <a:p/>
+              </p:txBody>
             </p:sp>
           </p:grpSp>
           <p:sp>
@@ -3089,6 +3225,10 @@
                 </ns2:outerShdw>
               </ns2:effectLst>
             </p:spPr>
+            <p:txBody xmlns:a="http://schemas.openxmlformats.org/drawingml/2006/main">
+              <a:bodyPr/>
+              <a:p/>
+            </p:txBody>
           </p:sp>
           <p:sp>
             <p:nvSpPr>
@@ -3119,7 +3259,7 @@
                     <ns7:solidFill>
                       <ns7:srgbClr val="222222"/>
                     </ns7:solidFill>
-                    <ns7:latin typeface="Arial"/>
+                    <ns7:latin typeface="Times New Roman"/>
                     <ns7:ea typeface="Times New Roman"/>
                   </ns7:rPr>
                   <ns7:t>Tool trajectories</ns7:t>
@@ -3156,7 +3296,7 @@
                     <ns7:solidFill>
                       <ns7:srgbClr val="222222"/>
                     </ns7:solidFill>
-                    <ns7:latin typeface="Arial"/>
+                    <ns7:latin typeface="Times New Roman"/>
                     <ns7:ea typeface="Times New Roman"/>
                   </ns7:rPr>
                   <ns7:t>Action policy</ns7:t>
@@ -3193,7 +3333,7 @@
                     <ns7:solidFill>
                       <ns7:srgbClr val="222222"/>
                     </ns7:solidFill>
-                    <ns7:latin typeface="Arial"/>
+                    <ns7:latin typeface="Times New Roman"/>
                     <ns7:ea typeface="Times New Roman"/>
                   </ns7:rPr>
                   <ns7:t>Execution and preference feedback</ns7:t>
@@ -3237,6 +3377,10 @@
               </ns4:solidFill>
             </ns4:ln>
           </p:spPr>
+          <p:txBody xmlns:a="http://schemas.openxmlformats.org/drawingml/2006/main">
+            <a:bodyPr/>
+            <a:p/>
+          </p:txBody>
         </p:sp>
         <p:grpSp>
           <p:nvGrpSpPr>
@@ -3330,6 +3474,10 @@
                 </ns4:solidFill>
               </ns4:ln>
             </p:spPr>
+            <p:txBody xmlns:a="http://schemas.openxmlformats.org/drawingml/2006/main">
+              <a:bodyPr/>
+              <a:p/>
+            </p:txBody>
           </p:sp>
           <p:sp>
             <p:nvSpPr>
@@ -3400,6 +3548,10 @@
                 </ns4:solidFill>
               </ns4:ln>
             </p:spPr>
+            <p:txBody xmlns:a="http://schemas.openxmlformats.org/drawingml/2006/main">
+              <a:bodyPr/>
+              <a:p/>
+            </p:txBody>
           </p:sp>
         </p:grpSp>
         <p:sp>
@@ -3470,6 +3622,10 @@
               </ns4:solidFill>
             </ns4:ln>
           </p:spPr>
+          <p:txBody xmlns:a="http://schemas.openxmlformats.org/drawingml/2006/main">
+            <a:bodyPr/>
+            <a:p/>
+          </p:txBody>
         </p:sp>
         <p:sp>
           <p:nvSpPr>
@@ -3500,7 +3656,7 @@
                   <ns7:solidFill>
                     <ns7:srgbClr val="222222"/>
                   </ns7:solidFill>
-                  <ns7:latin typeface="Arial"/>
+                  <ns7:latin typeface="Times New Roman"/>
                   <ns7:ea typeface="Times New Roman"/>
                 </ns7:rPr>
                 <ns7:t>Observations</ns7:t>
@@ -3560,6 +3716,10 @@
                 </ns4:solidFill>
               </ns4:ln>
             </p:spPr>
+            <p:txBody xmlns:a="http://schemas.openxmlformats.org/drawingml/2006/main">
+              <a:bodyPr/>
+              <a:p/>
+            </p:txBody>
           </p:sp>
           <p:sp>
             <p:nvSpPr>
@@ -3582,6 +3742,10 @@
                 </ns5:solidFill>
               </ns5:ln>
             </p:spPr>
+            <p:txBody xmlns:a="http://schemas.openxmlformats.org/drawingml/2006/main">
+              <a:bodyPr/>
+              <a:p/>
+            </p:txBody>
           </p:sp>
           <p:sp>
             <p:nvSpPr>
@@ -3618,6 +3782,10 @@
                 </ns4:solidFill>
               </ns4:ln>
             </p:spPr>
+            <p:txBody xmlns:a="http://schemas.openxmlformats.org/drawingml/2006/main">
+              <a:bodyPr/>
+              <a:p/>
+            </p:txBody>
           </p:sp>
           <p:sp>
             <p:nvSpPr>
@@ -3654,6 +3822,10 @@
                 </ns4:solidFill>
               </ns4:ln>
             </p:spPr>
+            <p:txBody xmlns:a="http://schemas.openxmlformats.org/drawingml/2006/main">
+              <a:bodyPr/>
+              <a:p/>
+            </p:txBody>
           </p:sp>
           <p:sp>
             <p:nvSpPr>
@@ -3690,6 +3862,10 @@
                 </ns4:solidFill>
               </ns4:ln>
             </p:spPr>
+            <p:txBody xmlns:a="http://schemas.openxmlformats.org/drawingml/2006/main">
+              <a:bodyPr/>
+              <a:p/>
+            </p:txBody>
           </p:sp>
           <p:sp>
             <p:nvSpPr>
@@ -3726,6 +3902,10 @@
                 </ns4:solidFill>
               </ns4:ln>
             </p:spPr>
+            <p:txBody xmlns:a="http://schemas.openxmlformats.org/drawingml/2006/main">
+              <a:bodyPr/>
+              <a:p/>
+            </p:txBody>
           </p:sp>
         </p:grpSp>
         <p:sp>
@@ -3757,7 +3937,7 @@
                   <ns7:solidFill>
                     <ns7:srgbClr val="222222"/>
                   </ns7:solidFill>
-                  <ns7:latin typeface="Comic Sans MS"/>
+                  <ns7:latin typeface="Times New Roman"/>
                   <ns7:ea typeface="Times New Roman"/>
                 </ns7:rPr>
                 <ns7:t>LLM</ns7:t>
@@ -3877,6 +4057,10 @@
                 </ns4:solidFill>
               </ns4:ln>
             </p:spPr>
+            <p:txBody xmlns:a="http://schemas.openxmlformats.org/drawingml/2006/main">
+              <a:bodyPr/>
+              <a:p/>
+            </p:txBody>
           </p:sp>
         </p:grpSp>
         <p:sp>
@@ -3908,7 +4092,7 @@
                   <ns7:solidFill>
                     <ns7:srgbClr val="222222"/>
                   </ns7:solidFill>
-                  <ns7:latin typeface="Arial"/>
+                  <ns7:latin typeface="Times New Roman"/>
                   <ns7:ea typeface="Times New Roman"/>
                 </ns7:rPr>
                 <ns7:t>Tool actions</ns7:t>
@@ -3965,6 +4149,10 @@
                 </ns4:solidFill>
               </ns4:ln>
             </p:spPr>
+            <p:txBody xmlns:a="http://schemas.openxmlformats.org/drawingml/2006/main">
+              <a:bodyPr/>
+              <a:p/>
+            </p:txBody>
           </p:sp>
           <p:sp>
             <p:nvSpPr>
@@ -4001,6 +4189,10 @@
                 </ns4:solidFill>
               </ns4:ln>
             </p:spPr>
+            <p:txBody xmlns:a="http://schemas.openxmlformats.org/drawingml/2006/main">
+              <a:bodyPr/>
+              <a:p/>
+            </p:txBody>
           </p:sp>
           <p:sp>
             <p:nvSpPr>
@@ -4037,6 +4229,10 @@
                 </ns4:solidFill>
               </ns4:ln>
             </p:spPr>
+            <p:txBody xmlns:a="http://schemas.openxmlformats.org/drawingml/2006/main">
+              <a:bodyPr/>
+              <a:p/>
+            </p:txBody>
           </p:sp>
           <p:sp>
             <p:nvSpPr>
@@ -4094,6 +4290,10 @@
                 </ns4:solidFill>
               </ns4:ln>
             </p:spPr>
+            <p:txBody xmlns:a="http://schemas.openxmlformats.org/drawingml/2006/main">
+              <a:bodyPr/>
+              <a:p/>
+            </p:txBody>
           </p:sp>
           <p:sp>
             <p:nvSpPr>
@@ -4130,6 +4330,10 @@
                 </ns4:solidFill>
               </ns4:ln>
             </p:spPr>
+            <p:txBody xmlns:a="http://schemas.openxmlformats.org/drawingml/2006/main">
+              <a:bodyPr/>
+              <a:p/>
+            </p:txBody>
           </p:sp>
           <p:sp>
             <p:nvSpPr>
@@ -4166,6 +4370,10 @@
                 </ns4:solidFill>
               </ns4:ln>
             </p:spPr>
+            <p:txBody xmlns:a="http://schemas.openxmlformats.org/drawingml/2006/main">
+              <a:bodyPr/>
+              <a:p/>
+            </p:txBody>
           </p:sp>
         </p:grpSp>
         <p:sp>
@@ -4197,7 +4405,7 @@
                   <ns7:solidFill>
                     <ns7:srgbClr val="222222"/>
                   </ns7:solidFill>
-                  <ns7:latin typeface="Arial"/>
+                  <ns7:latin typeface="Times New Roman"/>
                   <ns7:ea typeface="Times New Roman"/>
                 </ns7:rPr>
                 <ns7:t>Outputs</ns7:t>
@@ -4256,6 +4464,10 @@
               </ns3:outerShdw>
             </ns3:effectLst>
           </p:spPr>
+          <p:txBody xmlns:a="http://schemas.openxmlformats.org/drawingml/2006/main">
+            <a:bodyPr/>
+            <a:p/>
+          </p:txBody>
         </p:sp>
         <p:sp>
           <p:nvSpPr>
@@ -4286,7 +4498,7 @@
                   <ns7:solidFill>
                     <ns7:srgbClr val="222222"/>
                   </ns7:solidFill>
-                  <ns7:latin typeface="Arial"/>
+                  <ns7:latin typeface="Times New Roman"/>
                   <ns7:ea typeface="Times New Roman"/>
                 </ns7:rPr>
                 <ns7:t>Encode / retrieve</ns7:t>
@@ -4345,6 +4557,10 @@
               </ns4:outerShdw>
             </ns4:effectLst>
           </p:spPr>
+          <p:txBody xmlns:a="http://schemas.openxmlformats.org/drawingml/2006/main">
+            <a:bodyPr/>
+            <a:p/>
+          </p:txBody>
         </p:sp>
         <p:sp>
           <p:nvSpPr>
@@ -4375,7 +4591,7 @@
                   <ns7:solidFill>
                     <ns7:srgbClr val="222222"/>
                   </ns7:solidFill>
-                  <ns7:latin typeface="Arial"/>
+                  <ns7:latin typeface="Times New Roman"/>
                   <ns7:ea typeface="Times New Roman"/>
                 </ns7:rPr>
                 <ns7:t>Select and assess</ns7:t>
@@ -4440,6 +4656,10 @@
               </ns5:outerShdw>
             </ns5:effectLst>
           </p:spPr>
+          <p:txBody xmlns:a="http://schemas.openxmlformats.org/drawingml/2006/main">
+            <a:bodyPr/>
+            <a:p/>
+          </p:txBody>
         </p:sp>
         <p:sp>
           <p:nvSpPr>
@@ -4470,7 +4690,7 @@
                   <ns7:solidFill>
                     <ns7:srgbClr val="222222"/>
                   </ns7:solidFill>
-                  <ns7:latin typeface="Arial"/>
+                  <ns7:latin typeface="Times New Roman"/>
                   <ns7:ea typeface="Times New Roman"/>
                 </ns7:rPr>
                 <ns7:t>Harness: execution, state and feedback</ns7:t>
@@ -4513,6 +4733,10 @@
                 </ns5:solidFill>
               </ns5:ln>
             </p:spPr>
+            <p:txBody xmlns:a="http://schemas.openxmlformats.org/drawingml/2006/main">
+              <a:bodyPr/>
+              <a:p/>
+            </p:txBody>
           </p:sp>
           <p:sp>
             <p:nvSpPr>
@@ -4535,6 +4759,10 @@
                 </ns5:solidFill>
               </ns5:ln>
             </p:spPr>
+            <p:txBody xmlns:a="http://schemas.openxmlformats.org/drawingml/2006/main">
+              <a:bodyPr/>
+              <a:p/>
+            </p:txBody>
           </p:sp>
           <p:sp>
             <p:nvSpPr>
@@ -4557,6 +4785,10 @@
                 </ns5:solidFill>
               </ns5:ln>
             </p:spPr>
+            <p:txBody xmlns:a="http://schemas.openxmlformats.org/drawingml/2006/main">
+              <a:bodyPr/>
+              <a:p/>
+            </p:txBody>
           </p:sp>
         </p:grpSp>
         <p:sp>
@@ -4588,7 +4820,7 @@
                   <ns7:solidFill>
                     <ns7:srgbClr val="222222"/>
                   </ns7:solidFill>
-                  <ns7:latin typeface="Arial"/>
+                  <ns7:latin typeface="Times New Roman"/>
                   <ns7:ea typeface="Times New Roman"/>
                 </ns7:rPr>
                 <ns7:t>Forecast accuracy</ns7:t>
@@ -4653,6 +4885,10 @@
                 </ns4:solidFill>
               </ns4:ln>
             </p:spPr>
+            <p:txBody xmlns:a="http://schemas.openxmlformats.org/drawingml/2006/main">
+              <a:bodyPr/>
+              <a:p/>
+            </p:txBody>
           </p:sp>
           <p:sp>
             <p:nvSpPr>
@@ -4697,6 +4933,10 @@
                 </ns4:solidFill>
               </ns4:ln>
             </p:spPr>
+            <p:txBody xmlns:a="http://schemas.openxmlformats.org/drawingml/2006/main">
+              <a:bodyPr/>
+              <a:p/>
+            </p:txBody>
           </p:sp>
           <p:sp>
             <p:nvSpPr>
@@ -4741,6 +4981,10 @@
                 </ns4:solidFill>
               </ns4:ln>
             </p:spPr>
+            <p:txBody xmlns:a="http://schemas.openxmlformats.org/drawingml/2006/main">
+              <a:bodyPr/>
+              <a:p/>
+            </p:txBody>
           </p:sp>
           <p:sp>
             <p:nvSpPr>
@@ -4785,6 +5029,10 @@
                 </ns4:solidFill>
               </ns4:ln>
             </p:spPr>
+            <p:txBody xmlns:a="http://schemas.openxmlformats.org/drawingml/2006/main">
+              <a:bodyPr/>
+              <a:p/>
+            </p:txBody>
           </p:sp>
           <p:sp>
             <p:nvSpPr>
@@ -4807,6 +5055,10 @@
                 </ns5:solidFill>
               </ns5:ln>
             </p:spPr>
+            <p:txBody xmlns:a="http://schemas.openxmlformats.org/drawingml/2006/main">
+              <a:bodyPr/>
+              <a:p/>
+            </p:txBody>
           </p:sp>
           <p:sp>
             <p:nvSpPr>
@@ -4843,6 +5095,10 @@
                 </ns4:solidFill>
               </ns4:ln>
             </p:spPr>
+            <p:txBody xmlns:a="http://schemas.openxmlformats.org/drawingml/2006/main">
+              <a:bodyPr/>
+              <a:p/>
+            </p:txBody>
           </p:sp>
         </p:grpSp>
         <p:sp>
@@ -4874,7 +5130,7 @@
                   <ns7:solidFill>
                     <ns7:srgbClr val="222222"/>
                   </ns7:solidFill>
-                  <ns7:latin typeface="Arial"/>
+                  <ns7:latin typeface="Times New Roman"/>
                   <ns7:ea typeface="Times New Roman"/>
                 </ns7:rPr>
                 <ns7:t>Explanation faithfulness</ns7:t>
@@ -4931,6 +5187,10 @@
                 </ns4:solidFill>
               </ns4:ln>
             </p:spPr>
+            <p:txBody xmlns:a="http://schemas.openxmlformats.org/drawingml/2006/main">
+              <a:bodyPr/>
+              <a:p/>
+            </p:txBody>
           </p:sp>
           <p:sp>
             <p:nvSpPr>
@@ -5023,6 +5283,10 @@
                 </ns4:solidFill>
               </ns4:ln>
             </p:spPr>
+            <p:txBody xmlns:a="http://schemas.openxmlformats.org/drawingml/2006/main">
+              <a:bodyPr/>
+              <a:p/>
+            </p:txBody>
           </p:sp>
         </p:grpSp>
         <p:sp>
@@ -5054,7 +5318,7 @@
                   <ns7:solidFill>
                     <ns7:srgbClr val="222222"/>
                   </ns7:solidFill>
-                  <ns7:latin typeface="Arial"/>
+                  <ns7:latin typeface="Times New Roman"/>
                   <ns7:ea typeface="Times New Roman"/>
                 </ns7:rPr>
                 <ns7:t>Evidence grounding</ns7:t>
@@ -5097,6 +5361,10 @@
                 </ns5:solidFill>
               </ns5:ln>
             </p:spPr>
+            <p:txBody xmlns:a="http://schemas.openxmlformats.org/drawingml/2006/main">
+              <a:bodyPr/>
+              <a:p/>
+            </p:txBody>
           </p:sp>
           <p:sp>
             <p:nvSpPr>
@@ -5136,6 +5404,10 @@
                 </ns4:solidFill>
               </ns4:ln>
             </p:spPr>
+            <p:txBody xmlns:a="http://schemas.openxmlformats.org/drawingml/2006/main">
+              <a:bodyPr/>
+              <a:p/>
+            </p:txBody>
           </p:sp>
         </p:grpSp>
         <p:sp>
@@ -5167,7 +5439,7 @@
                   <ns7:solidFill>
                     <ns7:srgbClr val="222222"/>
                   </ns7:solidFill>
-                  <ns7:latin typeface="Arial"/>
+                  <ns7:latin typeface="Times New Roman"/>
                   <ns7:ea typeface="Times New Roman"/>
                 </ns7:rPr>
                 <ns7:t>Action quality</ns7:t>

</xml_diff>

<commit_message>
Figure 1 as a define-build-evaluate-advance flow; restore original figure fonts
- Figure 1: four stages with arrows and an evaluation feedback loop; the build stage shows the LLM side beside the Harness layers from general to specific; section titles only; editorial styling (dashed boxes, Comic Sans headings) with layer tints from Figure 3
- Figures 4-15: revert the Times New Roman change; Comic Sans headings and Arial labels as before
- Caption and Section 1 text follow the new figure

Co-Authored-By: Claude Opus 5.5 <noreply@anthropic.com>
</commit_message>
<xml_diff>
--- a/artifacts/editorial_accent_20261022/pptx/Figure05_Accent.pptx
+++ b/artifacts/editorial_accent_20261022/pptx/Figure05_Accent.pptx
@@ -1143,7 +1143,7 @@
                     <ns7:solidFill>
                       <ns7:srgbClr val="222222"/>
                     </ns7:solidFill>
-                    <ns7:latin typeface="Times New Roman"/>
+                    <ns7:latin typeface="Comic Sans MS"/>
                     <ns7:ea typeface="Times New Roman"/>
                   </ns7:rPr>
                   <ns7:t>Representation &amp; alignment</ns7:t>
@@ -1200,10 +1200,6 @@
                   </ns4:solidFill>
                 </ns4:ln>
               </p:spPr>
-              <p:txBody xmlns:a="http://schemas.openxmlformats.org/drawingml/2006/main">
-                <a:bodyPr/>
-                <a:p/>
-              </p:txBody>
             </p:sp>
             <p:sp>
               <p:nvSpPr>
@@ -1240,10 +1236,6 @@
                   </ns4:solidFill>
                 </ns4:ln>
               </p:spPr>
-              <p:txBody xmlns:a="http://schemas.openxmlformats.org/drawingml/2006/main">
-                <a:bodyPr/>
-                <a:p/>
-              </p:txBody>
             </p:sp>
             <p:sp>
               <p:nvSpPr>
@@ -1280,10 +1272,6 @@
                   </ns4:solidFill>
                 </ns4:ln>
               </p:spPr>
-              <p:txBody xmlns:a="http://schemas.openxmlformats.org/drawingml/2006/main">
-                <a:bodyPr/>
-                <a:p/>
-              </p:txBody>
             </p:sp>
             <p:sp>
               <p:nvSpPr>
@@ -1341,10 +1329,6 @@
                   </ns4:solidFill>
                 </ns4:ln>
               </p:spPr>
-              <p:txBody xmlns:a="http://schemas.openxmlformats.org/drawingml/2006/main">
-                <a:bodyPr/>
-                <a:p/>
-              </p:txBody>
             </p:sp>
             <p:sp>
               <p:nvSpPr>
@@ -1381,10 +1365,6 @@
                   </ns4:solidFill>
                 </ns4:ln>
               </p:spPr>
-              <p:txBody xmlns:a="http://schemas.openxmlformats.org/drawingml/2006/main">
-                <a:bodyPr/>
-                <a:p/>
-              </p:txBody>
             </p:sp>
             <p:sp>
               <p:nvSpPr>
@@ -1421,10 +1401,6 @@
                   </ns4:solidFill>
                 </ns4:ln>
               </p:spPr>
-              <p:txBody xmlns:a="http://schemas.openxmlformats.org/drawingml/2006/main">
-                <a:bodyPr/>
-                <a:p/>
-              </p:txBody>
             </p:sp>
           </p:grpSp>
           <p:grpSp>
@@ -1516,10 +1492,6 @@
                   </ns4:solidFill>
                 </ns4:ln>
               </p:spPr>
-              <p:txBody xmlns:a="http://schemas.openxmlformats.org/drawingml/2006/main">
-                <a:bodyPr/>
-                <a:p/>
-              </p:txBody>
             </p:sp>
             <p:sp>
               <p:nvSpPr>
@@ -1574,10 +1546,6 @@
                   </ns4:solidFill>
                 </ns4:ln>
               </p:spPr>
-              <p:txBody xmlns:a="http://schemas.openxmlformats.org/drawingml/2006/main">
-                <a:bodyPr/>
-                <a:p/>
-              </p:txBody>
             </p:sp>
             <p:sp>
               <p:nvSpPr>
@@ -1632,10 +1600,6 @@
                   </ns4:solidFill>
                 </ns4:ln>
               </p:spPr>
-              <p:txBody xmlns:a="http://schemas.openxmlformats.org/drawingml/2006/main">
-                <a:bodyPr/>
-                <a:p/>
-              </p:txBody>
             </p:sp>
           </p:grpSp>
           <p:sp>
@@ -1689,10 +1653,6 @@
                 </ns0:outerShdw>
               </ns0:effectLst>
             </p:spPr>
-            <p:txBody xmlns:a="http://schemas.openxmlformats.org/drawingml/2006/main">
-              <a:bodyPr/>
-              <a:p/>
-            </p:txBody>
           </p:sp>
           <p:sp>
             <p:nvSpPr>
@@ -1723,7 +1683,7 @@
                     <ns7:solidFill>
                       <ns7:srgbClr val="222222"/>
                     </ns7:solidFill>
-                    <ns7:latin typeface="Times New Roman"/>
+                    <ns7:latin typeface="Arial"/>
                     <ns7:ea typeface="Times New Roman"/>
                   </ns7:rPr>
                   <ns7:t>Series patches</ns7:t>
@@ -1760,7 +1720,7 @@
                     <ns7:solidFill>
                       <ns7:srgbClr val="222222"/>
                     </ns7:solidFill>
-                    <ns7:latin typeface="Times New Roman"/>
+                    <ns7:latin typeface="Arial"/>
                     <ns7:ea typeface="Times New Roman"/>
                   </ns7:rPr>
                   <ns7:t>Language space</ns7:t>
@@ -1797,7 +1757,7 @@
                     <ns7:solidFill>
                       <ns7:srgbClr val="222222"/>
                     </ns7:solidFill>
-                    <ns7:latin typeface="Times New Roman"/>
+                    <ns7:latin typeface="Arial"/>
                     <ns7:ea typeface="Times New Roman"/>
                   </ns7:rPr>
                   <ns7:t>Scale and temporal structure</ns7:t>
@@ -1849,7 +1809,7 @@
                     <ns7:solidFill>
                       <ns7:srgbClr val="222222"/>
                     </ns7:solidFill>
-                    <ns7:latin typeface="Times New Roman"/>
+                    <ns7:latin typeface="Comic Sans MS"/>
                     <ns7:ea typeface="Times New Roman"/>
                   </ns7:rPr>
                   <ns7:t>Instruction &amp; reasoning</ns7:t>
@@ -1944,10 +1904,6 @@
                   </ns4:solidFill>
                 </ns4:ln>
               </p:spPr>
-              <p:txBody xmlns:a="http://schemas.openxmlformats.org/drawingml/2006/main">
-                <a:bodyPr/>
-                <a:p/>
-              </p:txBody>
             </p:sp>
             <p:sp>
               <p:nvSpPr>
@@ -1992,10 +1948,6 @@
                   </ns4:solidFill>
                 </ns4:ln>
               </p:spPr>
-              <p:txBody xmlns:a="http://schemas.openxmlformats.org/drawingml/2006/main">
-                <a:bodyPr/>
-                <a:p/>
-              </p:txBody>
             </p:sp>
             <p:sp>
               <p:nvSpPr>
@@ -2032,10 +1984,6 @@
                   </ns4:solidFill>
                 </ns4:ln>
               </p:spPr>
-              <p:txBody xmlns:a="http://schemas.openxmlformats.org/drawingml/2006/main">
-                <a:bodyPr/>
-                <a:p/>
-              </p:txBody>
             </p:sp>
             <p:sp>
               <p:nvSpPr>
@@ -2072,10 +2020,6 @@
                   </ns4:solidFill>
                 </ns4:ln>
               </p:spPr>
-              <p:txBody xmlns:a="http://schemas.openxmlformats.org/drawingml/2006/main">
-                <a:bodyPr/>
-                <a:p/>
-              </p:txBody>
             </p:sp>
             <p:sp>
               <p:nvSpPr>
@@ -2112,10 +2056,6 @@
                   </ns4:solidFill>
                 </ns4:ln>
               </p:spPr>
-              <p:txBody xmlns:a="http://schemas.openxmlformats.org/drawingml/2006/main">
-                <a:bodyPr/>
-                <a:p/>
-              </p:txBody>
             </p:sp>
           </p:grpSp>
           <p:grpSp>
@@ -2167,10 +2107,6 @@
                   </ns4:solidFill>
                 </ns4:ln>
               </p:spPr>
-              <p:txBody xmlns:a="http://schemas.openxmlformats.org/drawingml/2006/main">
-                <a:bodyPr/>
-                <a:p/>
-              </p:txBody>
             </p:sp>
             <p:sp>
               <p:nvSpPr>
@@ -2215,10 +2151,6 @@
                   </ns4:solidFill>
                 </ns4:ln>
               </p:spPr>
-              <p:txBody xmlns:a="http://schemas.openxmlformats.org/drawingml/2006/main">
-                <a:bodyPr/>
-                <a:p/>
-              </p:txBody>
             </p:sp>
             <p:sp>
               <p:nvSpPr>
@@ -2255,10 +2187,6 @@
                   </ns4:solidFill>
                 </ns4:ln>
               </p:spPr>
-              <p:txBody xmlns:a="http://schemas.openxmlformats.org/drawingml/2006/main">
-                <a:bodyPr/>
-                <a:p/>
-              </p:txBody>
             </p:sp>
             <p:sp>
               <p:nvSpPr>
@@ -2297,10 +2225,6 @@
                   </ns4:solidFill>
                 </ns4:ln>
               </p:spPr>
-              <p:txBody xmlns:a="http://schemas.openxmlformats.org/drawingml/2006/main">
-                <a:bodyPr/>
-                <a:p/>
-              </p:txBody>
             </p:sp>
             <p:sp>
               <p:nvSpPr>
@@ -2342,10 +2266,6 @@
                   </ns4:solidFill>
                 </ns4:ln>
               </p:spPr>
-              <p:txBody xmlns:a="http://schemas.openxmlformats.org/drawingml/2006/main">
-                <a:bodyPr/>
-                <a:p/>
-              </p:txBody>
             </p:sp>
             <p:sp>
               <p:nvSpPr>
@@ -2389,10 +2309,6 @@
                   </ns4:solidFill>
                 </ns4:ln>
               </p:spPr>
-              <p:txBody xmlns:a="http://schemas.openxmlformats.org/drawingml/2006/main">
-                <a:bodyPr/>
-                <a:p/>
-              </p:txBody>
             </p:sp>
             <p:sp>
               <p:nvSpPr>
@@ -2436,10 +2352,6 @@
                   </ns4:solidFill>
                 </ns4:ln>
               </p:spPr>
-              <p:txBody xmlns:a="http://schemas.openxmlformats.org/drawingml/2006/main">
-                <a:bodyPr/>
-                <a:p/>
-              </p:txBody>
             </p:sp>
             <p:sp>
               <p:nvSpPr>
@@ -2506,10 +2418,6 @@
                   </ns4:solidFill>
                 </ns4:ln>
               </p:spPr>
-              <p:txBody xmlns:a="http://schemas.openxmlformats.org/drawingml/2006/main">
-                <a:bodyPr/>
-                <a:p/>
-              </p:txBody>
             </p:sp>
             <p:sp>
               <p:nvSpPr>
@@ -2532,10 +2440,6 @@
                   </ns5:solidFill>
                 </ns5:ln>
               </p:spPr>
-              <p:txBody xmlns:a="http://schemas.openxmlformats.org/drawingml/2006/main">
-                <a:bodyPr/>
-                <a:p/>
-              </p:txBody>
             </p:sp>
             <p:sp>
               <p:nvSpPr>
@@ -2558,10 +2462,6 @@
                   </ns5:solidFill>
                 </ns5:ln>
               </p:spPr>
-              <p:txBody xmlns:a="http://schemas.openxmlformats.org/drawingml/2006/main">
-                <a:bodyPr/>
-                <a:p/>
-              </p:txBody>
             </p:sp>
             <p:sp>
               <p:nvSpPr>
@@ -2584,10 +2484,6 @@
                   </ns5:solidFill>
                 </ns5:ln>
               </p:spPr>
-              <p:txBody xmlns:a="http://schemas.openxmlformats.org/drawingml/2006/main">
-                <a:bodyPr/>
-                <a:p/>
-              </p:txBody>
             </p:sp>
             <p:sp>
               <p:nvSpPr>
@@ -2610,10 +2506,6 @@
                   </ns5:solidFill>
                 </ns5:ln>
               </p:spPr>
-              <p:txBody xmlns:a="http://schemas.openxmlformats.org/drawingml/2006/main">
-                <a:bodyPr/>
-                <a:p/>
-              </p:txBody>
             </p:sp>
           </p:grpSp>
           <p:sp>
@@ -2667,10 +2559,6 @@
                 </ns1:outerShdw>
               </ns1:effectLst>
             </p:spPr>
-            <p:txBody xmlns:a="http://schemas.openxmlformats.org/drawingml/2006/main">
-              <a:bodyPr/>
-              <a:p/>
-            </p:txBody>
           </p:sp>
           <p:sp>
             <p:nvSpPr>
@@ -2701,7 +2589,7 @@
                     <ns7:solidFill>
                       <ns7:srgbClr val="222222"/>
                     </ns7:solidFill>
-                    <ns7:latin typeface="Times New Roman"/>
+                    <ns7:latin typeface="Arial"/>
                     <ns7:ea typeface="Times New Roman"/>
                   </ns7:rPr>
                   <ns7:t>Temporal questions</ns7:t>
@@ -2738,7 +2626,7 @@
                     <ns7:solidFill>
                       <ns7:srgbClr val="222222"/>
                     </ns7:solidFill>
-                    <ns7:latin typeface="Times New Roman"/>
+                    <ns7:latin typeface="Arial"/>
                     <ns7:ea typeface="Times New Roman"/>
                   </ns7:rPr>
                   <ns7:t>Grounded answers</ns7:t>
@@ -2775,7 +2663,7 @@
                     <ns7:solidFill>
                       <ns7:srgbClr val="222222"/>
                     </ns7:solidFill>
-                    <ns7:latin typeface="Times New Roman"/>
+                    <ns7:latin typeface="Arial"/>
                     <ns7:ea typeface="Times New Roman"/>
                   </ns7:rPr>
                   <ns7:t>Instructions and outcome feedback</ns7:t>
@@ -2827,7 +2715,7 @@
                     <ns7:solidFill>
                       <ns7:srgbClr val="222222"/>
                     </ns7:solidFill>
-                    <ns7:latin typeface="Times New Roman"/>
+                    <ns7:latin typeface="Comic Sans MS"/>
                     <ns7:ea typeface="Times New Roman"/>
                   </ns7:rPr>
                   <ns7:t>Workflow learning</ns7:t>
@@ -2884,10 +2772,6 @@
                   </ns4:solidFill>
                 </ns4:ln>
               </p:spPr>
-              <p:txBody xmlns:a="http://schemas.openxmlformats.org/drawingml/2006/main">
-                <a:bodyPr/>
-                <a:p/>
-              </p:txBody>
             </p:sp>
             <p:sp>
               <p:nvSpPr>
@@ -2924,10 +2808,6 @@
                   </ns4:solidFill>
                 </ns4:ln>
               </p:spPr>
-              <p:txBody xmlns:a="http://schemas.openxmlformats.org/drawingml/2006/main">
-                <a:bodyPr/>
-                <a:p/>
-              </p:txBody>
             </p:sp>
             <p:sp>
               <p:nvSpPr>
@@ -2964,10 +2844,6 @@
                   </ns4:solidFill>
                 </ns4:ln>
               </p:spPr>
-              <p:txBody xmlns:a="http://schemas.openxmlformats.org/drawingml/2006/main">
-                <a:bodyPr/>
-                <a:p/>
-              </p:txBody>
             </p:sp>
             <p:sp>
               <p:nvSpPr>
@@ -3007,10 +2883,6 @@
                   </ns4:solidFill>
                 </ns4:ln>
               </p:spPr>
-              <p:txBody xmlns:a="http://schemas.openxmlformats.org/drawingml/2006/main">
-                <a:bodyPr/>
-                <a:p/>
-              </p:txBody>
             </p:sp>
             <p:sp>
               <p:nvSpPr>
@@ -3050,10 +2922,6 @@
                   </ns4:solidFill>
                 </ns4:ln>
               </p:spPr>
-              <p:txBody xmlns:a="http://schemas.openxmlformats.org/drawingml/2006/main">
-                <a:bodyPr/>
-                <a:p/>
-              </p:txBody>
             </p:sp>
           </p:grpSp>
           <p:grpSp>
@@ -3168,10 +3036,6 @@
                   </ns4:solidFill>
                 </ns4:ln>
               </p:spPr>
-              <p:txBody xmlns:a="http://schemas.openxmlformats.org/drawingml/2006/main">
-                <a:bodyPr/>
-                <a:p/>
-              </p:txBody>
             </p:sp>
           </p:grpSp>
           <p:sp>
@@ -3225,10 +3089,6 @@
                 </ns2:outerShdw>
               </ns2:effectLst>
             </p:spPr>
-            <p:txBody xmlns:a="http://schemas.openxmlformats.org/drawingml/2006/main">
-              <a:bodyPr/>
-              <a:p/>
-            </p:txBody>
           </p:sp>
           <p:sp>
             <p:nvSpPr>
@@ -3259,7 +3119,7 @@
                     <ns7:solidFill>
                       <ns7:srgbClr val="222222"/>
                     </ns7:solidFill>
-                    <ns7:latin typeface="Times New Roman"/>
+                    <ns7:latin typeface="Arial"/>
                     <ns7:ea typeface="Times New Roman"/>
                   </ns7:rPr>
                   <ns7:t>Tool trajectories</ns7:t>
@@ -3296,7 +3156,7 @@
                     <ns7:solidFill>
                       <ns7:srgbClr val="222222"/>
                     </ns7:solidFill>
-                    <ns7:latin typeface="Times New Roman"/>
+                    <ns7:latin typeface="Arial"/>
                     <ns7:ea typeface="Times New Roman"/>
                   </ns7:rPr>
                   <ns7:t>Action policy</ns7:t>
@@ -3333,7 +3193,7 @@
                     <ns7:solidFill>
                       <ns7:srgbClr val="222222"/>
                     </ns7:solidFill>
-                    <ns7:latin typeface="Times New Roman"/>
+                    <ns7:latin typeface="Arial"/>
                     <ns7:ea typeface="Times New Roman"/>
                   </ns7:rPr>
                   <ns7:t>Execution and preference feedback</ns7:t>
@@ -3377,10 +3237,6 @@
               </ns4:solidFill>
             </ns4:ln>
           </p:spPr>
-          <p:txBody xmlns:a="http://schemas.openxmlformats.org/drawingml/2006/main">
-            <a:bodyPr/>
-            <a:p/>
-          </p:txBody>
         </p:sp>
         <p:grpSp>
           <p:nvGrpSpPr>
@@ -3474,10 +3330,6 @@
                 </ns4:solidFill>
               </ns4:ln>
             </p:spPr>
-            <p:txBody xmlns:a="http://schemas.openxmlformats.org/drawingml/2006/main">
-              <a:bodyPr/>
-              <a:p/>
-            </p:txBody>
           </p:sp>
           <p:sp>
             <p:nvSpPr>
@@ -3548,10 +3400,6 @@
                 </ns4:solidFill>
               </ns4:ln>
             </p:spPr>
-            <p:txBody xmlns:a="http://schemas.openxmlformats.org/drawingml/2006/main">
-              <a:bodyPr/>
-              <a:p/>
-            </p:txBody>
           </p:sp>
         </p:grpSp>
         <p:sp>
@@ -3622,10 +3470,6 @@
               </ns4:solidFill>
             </ns4:ln>
           </p:spPr>
-          <p:txBody xmlns:a="http://schemas.openxmlformats.org/drawingml/2006/main">
-            <a:bodyPr/>
-            <a:p/>
-          </p:txBody>
         </p:sp>
         <p:sp>
           <p:nvSpPr>
@@ -3656,7 +3500,7 @@
                   <ns7:solidFill>
                     <ns7:srgbClr val="222222"/>
                   </ns7:solidFill>
-                  <ns7:latin typeface="Times New Roman"/>
+                  <ns7:latin typeface="Arial"/>
                   <ns7:ea typeface="Times New Roman"/>
                 </ns7:rPr>
                 <ns7:t>Observations</ns7:t>
@@ -3716,10 +3560,6 @@
                 </ns4:solidFill>
               </ns4:ln>
             </p:spPr>
-            <p:txBody xmlns:a="http://schemas.openxmlformats.org/drawingml/2006/main">
-              <a:bodyPr/>
-              <a:p/>
-            </p:txBody>
           </p:sp>
           <p:sp>
             <p:nvSpPr>
@@ -3742,10 +3582,6 @@
                 </ns5:solidFill>
               </ns5:ln>
             </p:spPr>
-            <p:txBody xmlns:a="http://schemas.openxmlformats.org/drawingml/2006/main">
-              <a:bodyPr/>
-              <a:p/>
-            </p:txBody>
           </p:sp>
           <p:sp>
             <p:nvSpPr>
@@ -3782,10 +3618,6 @@
                 </ns4:solidFill>
               </ns4:ln>
             </p:spPr>
-            <p:txBody xmlns:a="http://schemas.openxmlformats.org/drawingml/2006/main">
-              <a:bodyPr/>
-              <a:p/>
-            </p:txBody>
           </p:sp>
           <p:sp>
             <p:nvSpPr>
@@ -3822,10 +3654,6 @@
                 </ns4:solidFill>
               </ns4:ln>
             </p:spPr>
-            <p:txBody xmlns:a="http://schemas.openxmlformats.org/drawingml/2006/main">
-              <a:bodyPr/>
-              <a:p/>
-            </p:txBody>
           </p:sp>
           <p:sp>
             <p:nvSpPr>
@@ -3862,10 +3690,6 @@
                 </ns4:solidFill>
               </ns4:ln>
             </p:spPr>
-            <p:txBody xmlns:a="http://schemas.openxmlformats.org/drawingml/2006/main">
-              <a:bodyPr/>
-              <a:p/>
-            </p:txBody>
           </p:sp>
           <p:sp>
             <p:nvSpPr>
@@ -3902,10 +3726,6 @@
                 </ns4:solidFill>
               </ns4:ln>
             </p:spPr>
-            <p:txBody xmlns:a="http://schemas.openxmlformats.org/drawingml/2006/main">
-              <a:bodyPr/>
-              <a:p/>
-            </p:txBody>
           </p:sp>
         </p:grpSp>
         <p:sp>
@@ -3937,7 +3757,7 @@
                   <ns7:solidFill>
                     <ns7:srgbClr val="222222"/>
                   </ns7:solidFill>
-                  <ns7:latin typeface="Times New Roman"/>
+                  <ns7:latin typeface="Comic Sans MS"/>
                   <ns7:ea typeface="Times New Roman"/>
                 </ns7:rPr>
                 <ns7:t>LLM</ns7:t>
@@ -4057,10 +3877,6 @@
                 </ns4:solidFill>
               </ns4:ln>
             </p:spPr>
-            <p:txBody xmlns:a="http://schemas.openxmlformats.org/drawingml/2006/main">
-              <a:bodyPr/>
-              <a:p/>
-            </p:txBody>
           </p:sp>
         </p:grpSp>
         <p:sp>
@@ -4092,7 +3908,7 @@
                   <ns7:solidFill>
                     <ns7:srgbClr val="222222"/>
                   </ns7:solidFill>
-                  <ns7:latin typeface="Times New Roman"/>
+                  <ns7:latin typeface="Arial"/>
                   <ns7:ea typeface="Times New Roman"/>
                 </ns7:rPr>
                 <ns7:t>Tool actions</ns7:t>
@@ -4149,10 +3965,6 @@
                 </ns4:solidFill>
               </ns4:ln>
             </p:spPr>
-            <p:txBody xmlns:a="http://schemas.openxmlformats.org/drawingml/2006/main">
-              <a:bodyPr/>
-              <a:p/>
-            </p:txBody>
           </p:sp>
           <p:sp>
             <p:nvSpPr>
@@ -4189,10 +4001,6 @@
                 </ns4:solidFill>
               </ns4:ln>
             </p:spPr>
-            <p:txBody xmlns:a="http://schemas.openxmlformats.org/drawingml/2006/main">
-              <a:bodyPr/>
-              <a:p/>
-            </p:txBody>
           </p:sp>
           <p:sp>
             <p:nvSpPr>
@@ -4229,10 +4037,6 @@
                 </ns4:solidFill>
               </ns4:ln>
             </p:spPr>
-            <p:txBody xmlns:a="http://schemas.openxmlformats.org/drawingml/2006/main">
-              <a:bodyPr/>
-              <a:p/>
-            </p:txBody>
           </p:sp>
           <p:sp>
             <p:nvSpPr>
@@ -4290,10 +4094,6 @@
                 </ns4:solidFill>
               </ns4:ln>
             </p:spPr>
-            <p:txBody xmlns:a="http://schemas.openxmlformats.org/drawingml/2006/main">
-              <a:bodyPr/>
-              <a:p/>
-            </p:txBody>
           </p:sp>
           <p:sp>
             <p:nvSpPr>
@@ -4330,10 +4130,6 @@
                 </ns4:solidFill>
               </ns4:ln>
             </p:spPr>
-            <p:txBody xmlns:a="http://schemas.openxmlformats.org/drawingml/2006/main">
-              <a:bodyPr/>
-              <a:p/>
-            </p:txBody>
           </p:sp>
           <p:sp>
             <p:nvSpPr>
@@ -4370,10 +4166,6 @@
                 </ns4:solidFill>
               </ns4:ln>
             </p:spPr>
-            <p:txBody xmlns:a="http://schemas.openxmlformats.org/drawingml/2006/main">
-              <a:bodyPr/>
-              <a:p/>
-            </p:txBody>
           </p:sp>
         </p:grpSp>
         <p:sp>
@@ -4405,7 +4197,7 @@
                   <ns7:solidFill>
                     <ns7:srgbClr val="222222"/>
                   </ns7:solidFill>
-                  <ns7:latin typeface="Times New Roman"/>
+                  <ns7:latin typeface="Arial"/>
                   <ns7:ea typeface="Times New Roman"/>
                 </ns7:rPr>
                 <ns7:t>Outputs</ns7:t>
@@ -4464,10 +4256,6 @@
               </ns3:outerShdw>
             </ns3:effectLst>
           </p:spPr>
-          <p:txBody xmlns:a="http://schemas.openxmlformats.org/drawingml/2006/main">
-            <a:bodyPr/>
-            <a:p/>
-          </p:txBody>
         </p:sp>
         <p:sp>
           <p:nvSpPr>
@@ -4498,7 +4286,7 @@
                   <ns7:solidFill>
                     <ns7:srgbClr val="222222"/>
                   </ns7:solidFill>
-                  <ns7:latin typeface="Times New Roman"/>
+                  <ns7:latin typeface="Arial"/>
                   <ns7:ea typeface="Times New Roman"/>
                 </ns7:rPr>
                 <ns7:t>Encode / retrieve</ns7:t>
@@ -4557,10 +4345,6 @@
               </ns4:outerShdw>
             </ns4:effectLst>
           </p:spPr>
-          <p:txBody xmlns:a="http://schemas.openxmlformats.org/drawingml/2006/main">
-            <a:bodyPr/>
-            <a:p/>
-          </p:txBody>
         </p:sp>
         <p:sp>
           <p:nvSpPr>
@@ -4591,7 +4375,7 @@
                   <ns7:solidFill>
                     <ns7:srgbClr val="222222"/>
                   </ns7:solidFill>
-                  <ns7:latin typeface="Times New Roman"/>
+                  <ns7:latin typeface="Arial"/>
                   <ns7:ea typeface="Times New Roman"/>
                 </ns7:rPr>
                 <ns7:t>Select and assess</ns7:t>
@@ -4656,10 +4440,6 @@
               </ns5:outerShdw>
             </ns5:effectLst>
           </p:spPr>
-          <p:txBody xmlns:a="http://schemas.openxmlformats.org/drawingml/2006/main">
-            <a:bodyPr/>
-            <a:p/>
-          </p:txBody>
         </p:sp>
         <p:sp>
           <p:nvSpPr>
@@ -4690,7 +4470,7 @@
                   <ns7:solidFill>
                     <ns7:srgbClr val="222222"/>
                   </ns7:solidFill>
-                  <ns7:latin typeface="Times New Roman"/>
+                  <ns7:latin typeface="Arial"/>
                   <ns7:ea typeface="Times New Roman"/>
                 </ns7:rPr>
                 <ns7:t>Harness: execution, state and feedback</ns7:t>
@@ -4733,10 +4513,6 @@
                 </ns5:solidFill>
               </ns5:ln>
             </p:spPr>
-            <p:txBody xmlns:a="http://schemas.openxmlformats.org/drawingml/2006/main">
-              <a:bodyPr/>
-              <a:p/>
-            </p:txBody>
           </p:sp>
           <p:sp>
             <p:nvSpPr>
@@ -4759,10 +4535,6 @@
                 </ns5:solidFill>
               </ns5:ln>
             </p:spPr>
-            <p:txBody xmlns:a="http://schemas.openxmlformats.org/drawingml/2006/main">
-              <a:bodyPr/>
-              <a:p/>
-            </p:txBody>
           </p:sp>
           <p:sp>
             <p:nvSpPr>
@@ -4785,10 +4557,6 @@
                 </ns5:solidFill>
               </ns5:ln>
             </p:spPr>
-            <p:txBody xmlns:a="http://schemas.openxmlformats.org/drawingml/2006/main">
-              <a:bodyPr/>
-              <a:p/>
-            </p:txBody>
           </p:sp>
         </p:grpSp>
         <p:sp>
@@ -4820,7 +4588,7 @@
                   <ns7:solidFill>
                     <ns7:srgbClr val="222222"/>
                   </ns7:solidFill>
-                  <ns7:latin typeface="Times New Roman"/>
+                  <ns7:latin typeface="Arial"/>
                   <ns7:ea typeface="Times New Roman"/>
                 </ns7:rPr>
                 <ns7:t>Forecast accuracy</ns7:t>
@@ -4885,10 +4653,6 @@
                 </ns4:solidFill>
               </ns4:ln>
             </p:spPr>
-            <p:txBody xmlns:a="http://schemas.openxmlformats.org/drawingml/2006/main">
-              <a:bodyPr/>
-              <a:p/>
-            </p:txBody>
           </p:sp>
           <p:sp>
             <p:nvSpPr>
@@ -4933,10 +4697,6 @@
                 </ns4:solidFill>
               </ns4:ln>
             </p:spPr>
-            <p:txBody xmlns:a="http://schemas.openxmlformats.org/drawingml/2006/main">
-              <a:bodyPr/>
-              <a:p/>
-            </p:txBody>
           </p:sp>
           <p:sp>
             <p:nvSpPr>
@@ -4981,10 +4741,6 @@
                 </ns4:solidFill>
               </ns4:ln>
             </p:spPr>
-            <p:txBody xmlns:a="http://schemas.openxmlformats.org/drawingml/2006/main">
-              <a:bodyPr/>
-              <a:p/>
-            </p:txBody>
           </p:sp>
           <p:sp>
             <p:nvSpPr>
@@ -5029,10 +4785,6 @@
                 </ns4:solidFill>
               </ns4:ln>
             </p:spPr>
-            <p:txBody xmlns:a="http://schemas.openxmlformats.org/drawingml/2006/main">
-              <a:bodyPr/>
-              <a:p/>
-            </p:txBody>
           </p:sp>
           <p:sp>
             <p:nvSpPr>
@@ -5055,10 +4807,6 @@
                 </ns5:solidFill>
               </ns5:ln>
             </p:spPr>
-            <p:txBody xmlns:a="http://schemas.openxmlformats.org/drawingml/2006/main">
-              <a:bodyPr/>
-              <a:p/>
-            </p:txBody>
           </p:sp>
           <p:sp>
             <p:nvSpPr>
@@ -5095,10 +4843,6 @@
                 </ns4:solidFill>
               </ns4:ln>
             </p:spPr>
-            <p:txBody xmlns:a="http://schemas.openxmlformats.org/drawingml/2006/main">
-              <a:bodyPr/>
-              <a:p/>
-            </p:txBody>
           </p:sp>
         </p:grpSp>
         <p:sp>
@@ -5130,7 +4874,7 @@
                   <ns7:solidFill>
                     <ns7:srgbClr val="222222"/>
                   </ns7:solidFill>
-                  <ns7:latin typeface="Times New Roman"/>
+                  <ns7:latin typeface="Arial"/>
                   <ns7:ea typeface="Times New Roman"/>
                 </ns7:rPr>
                 <ns7:t>Explanation faithfulness</ns7:t>
@@ -5187,10 +4931,6 @@
                 </ns4:solidFill>
               </ns4:ln>
             </p:spPr>
-            <p:txBody xmlns:a="http://schemas.openxmlformats.org/drawingml/2006/main">
-              <a:bodyPr/>
-              <a:p/>
-            </p:txBody>
           </p:sp>
           <p:sp>
             <p:nvSpPr>
@@ -5283,10 +5023,6 @@
                 </ns4:solidFill>
               </ns4:ln>
             </p:spPr>
-            <p:txBody xmlns:a="http://schemas.openxmlformats.org/drawingml/2006/main">
-              <a:bodyPr/>
-              <a:p/>
-            </p:txBody>
           </p:sp>
         </p:grpSp>
         <p:sp>
@@ -5318,7 +5054,7 @@
                   <ns7:solidFill>
                     <ns7:srgbClr val="222222"/>
                   </ns7:solidFill>
-                  <ns7:latin typeface="Times New Roman"/>
+                  <ns7:latin typeface="Arial"/>
                   <ns7:ea typeface="Times New Roman"/>
                 </ns7:rPr>
                 <ns7:t>Evidence grounding</ns7:t>
@@ -5361,10 +5097,6 @@
                 </ns5:solidFill>
               </ns5:ln>
             </p:spPr>
-            <p:txBody xmlns:a="http://schemas.openxmlformats.org/drawingml/2006/main">
-              <a:bodyPr/>
-              <a:p/>
-            </p:txBody>
           </p:sp>
           <p:sp>
             <p:nvSpPr>
@@ -5404,10 +5136,6 @@
                 </ns4:solidFill>
               </ns4:ln>
             </p:spPr>
-            <p:txBody xmlns:a="http://schemas.openxmlformats.org/drawingml/2006/main">
-              <a:bodyPr/>
-              <a:p/>
-            </p:txBody>
           </p:sp>
         </p:grpSp>
         <p:sp>
@@ -5439,7 +5167,7 @@
                   <ns7:solidFill>
                     <ns7:srgbClr val="222222"/>
                   </ns7:solidFill>
-                  <ns7:latin typeface="Times New Roman"/>
+                  <ns7:latin typeface="Arial"/>
                   <ns7:ea typeface="Times New Roman"/>
                 </ns7:rPr>
                 <ns7:t>Action quality</ns7:t>

</xml_diff>